<commit_message>
Update TFM materials for public deployment
</commit_message>
<xml_diff>
--- a/entrega-tfm/ProgresIA-Studio-TFM-final.pptx
+++ b/entrega-tfm/ProgresIA-Studio-TFM-final.pptx
@@ -3700,21 +3700,14 @@
           <a:bodyPr xmlns:a="http://schemas.openxmlformats.org/drawingml/2006/main" anchor="t"/>
           <a:lstStyle xmlns:a="http://schemas.openxmlformats.org/drawingml/2006/main"/>
           <a:p xmlns:a="http://schemas.openxmlformats.org/drawingml/2006/main">
-            <a:pPr algn="l">
-              <a:buNone/>
-              <a:defRPr sz="1425" b="0">
-                <a:solidFill>
-                  <a:srgbClr val="111111"/>
-                </a:solidFill>
-              </a:defRPr>
-            </a:pPr>
-            <a:r>
-              <a:rPr sz="1425" b="0">
-                <a:solidFill>
-                  <a:srgbClr val="111111"/>
-                </a:solidFill>
-              </a:rPr>
-              <a:t>Exportación PDF, Markdown, ZIP y publicación en GitHub.</a:t>
+            <a:r>
+              <a:rPr sz="1700">
+                <a:solidFill>
+                  <a:srgbClr val="1E1E1E"/>
+                </a:solidFill>
+                <a:latin typeface="Aptos"/>
+              </a:rPr>
+              <a:t>Dominio publico online, health check y exportacion PDF/ZIP.</a:t>
             </a:r>
           </a:p>
         </p:txBody>
@@ -12413,7 +12406,7 @@
                   <a:srgbClr val="555555"/>
                 </a:solidFill>
               </a:rPr>
-              <a:t>PDF, Markdown y ZIP final.</a:t>
+              <a:t>Dominio, health y ZIP final.</a:t>
             </a:r>
           </a:p>
         </p:txBody>
@@ -13156,21 +13149,14 @@
           <a:bodyPr xmlns:a="http://schemas.openxmlformats.org/drawingml/2006/main" anchor="t"/>
           <a:lstStyle xmlns:a="http://schemas.openxmlformats.org/drawingml/2006/main"/>
           <a:p xmlns:a="http://schemas.openxmlformats.org/drawingml/2006/main">
-            <a:pPr algn="l">
-              <a:buNone/>
-              <a:defRPr sz="1425" b="0">
+            <a:r>
+              <a:rPr sz="1700">
                 <a:solidFill>
                   <a:srgbClr val="FFFFFF"/>
                 </a:solidFill>
-              </a:defRPr>
-            </a:pPr>
-            <a:r>
-              <a:rPr sz="1425" b="0">
-                <a:solidFill>
-                  <a:srgbClr val="FFFFFF"/>
-                </a:solidFill>
-              </a:rPr>
-              <a:t>Seguridad, validación y CI automatizada</a:t>
+                <a:latin typeface="Aptos"/>
+              </a:rPr>
+              <a:t>Servidor publico online + seguridad y CI</a:t>
             </a:r>
           </a:p>
         </p:txBody>
@@ -13591,21 +13577,14 @@
           <a:bodyPr xmlns:a="http://schemas.openxmlformats.org/drawingml/2006/main" anchor="t"/>
           <a:lstStyle xmlns:a="http://schemas.openxmlformats.org/drawingml/2006/main"/>
           <a:p xmlns:a="http://schemas.openxmlformats.org/drawingml/2006/main">
-            <a:pPr algn="l">
-              <a:buNone/>
-              <a:defRPr sz="1425" b="0">
-                <a:solidFill>
-                  <a:srgbClr val="111111"/>
-                </a:solidFill>
-              </a:defRPr>
-            </a:pPr>
-            <a:r>
-              <a:rPr sz="1425" b="0">
-                <a:solidFill>
-                  <a:srgbClr val="111111"/>
-                </a:solidFill>
-              </a:rPr>
-              <a:t>Despliegue público reproducible y observabilidad</a:t>
+            <a:r>
+              <a:rPr sz="1700">
+                <a:solidFill>
+                  <a:srgbClr val="1E1E1E"/>
+                </a:solidFill>
+                <a:latin typeface="Aptos"/>
+              </a:rPr>
+              <a:t>Automatizar despliegue CI/CD y activar Sentry</a:t>
             </a:r>
           </a:p>
         </p:txBody>
@@ -14201,7 +14180,8 @@
                   <a:srgbClr val="555555"/>
                 </a:solidFill>
               </a:rPr>
-              <a:t>github.com/seurob/progresia</a:t>
+              <a:t>progresia.alumnes-monlau.com
+github.com/seurob/progresia</a:t>
             </a:r>
           </a:p>
         </p:txBody>
@@ -23162,6 +23142,37 @@
                 </a:solidFill>
               </a:rPr>
               <a:t>Mailpit</a:t>
+            </a:r>
+          </a:p>
+        </p:txBody>
+      </p:sp>
+      <p:sp xmlns:a="http://schemas.openxmlformats.org/drawingml/2006/main">
+        <p:nvSpPr>
+          <p:cNvPr id="27" name="TextBox 26"/>
+          <p:cNvSpPr txBox="1"/>
+          <p:nvPr/>
+        </p:nvSpPr>
+        <p:spPr>
+          <a:xfrm>
+            <a:off x="685817" y="6144768"/>
+            <a:ext cx="10835910" cy="320040"/>
+          </a:xfrm>
+          <a:prstGeom prst="rect">
+            <a:avLst/>
+          </a:prstGeom>
+          <a:noFill/>
+        </p:spPr>
+        <p:txBody>
+          <a:bodyPr wrap="none">
+            <a:spAutoFit/>
+          </a:bodyPr>
+          <a:lstStyle/>
+          <a:p>
+            <a:r>
+              <a:rPr sz="1000">
+                <a:latin typeface="Aptos"/>
+              </a:rPr>
+              <a:t>Produccion: https://progresia.alumnes-monlau.com - Ubuntu/Plesk - Docker Compose - Nginx proxy</a:t>
             </a:r>
           </a:p>
         </p:txBody>

</xml_diff>